<commit_message>
Add presentation (PPTX and PDF) and refresh architecture diagram
</commit_message>
<xml_diff>
--- a/docs/Architecture.pptx
+++ b/docs/Architecture.pptx
@@ -108,7 +108,7 @@
   <p:extLst>
     <p:ext uri="{521415D9-36F7-43E2-AB2F-B90AF26B5E84}">
       <p14:sectionLst xmlns:p14="http://schemas.microsoft.com/office/powerpoint/2010/main">
-        <p14:section name="Architecture" id="{bc115bad-7b53-a88c-fa57-c1f4b554c9ac}">
+        <p14:section name="Architecture" id="{642b43fa-b4c1-cc3c-5efd-537d8ba9bf04}">
           <p14:sldIdLst>
             <p14:sldId id="256"/>
             <p14:sldId id="257"/>
@@ -881,7 +881,7 @@
                   <a:srgbClr val="898781"/>
                 </a:solidFill>
               </a:rPr>
-              <a:t>MadhuTwin architecture  ·  Team Name</a:t>
+              <a:t>MadhuTwin architecture  ·  Anish Karthik Ayyagari, IIT Kharagpur</a:t>
             </a:r>
             <a:endParaRPr lang="en-US" sz="900" dirty="0"/>
           </a:p>

</xml_diff>

<commit_message>
Add team name (BioT) to README, notice and slides
</commit_message>
<xml_diff>
--- a/docs/Architecture.pptx
+++ b/docs/Architecture.pptx
@@ -108,7 +108,7 @@
   <p:extLst>
     <p:ext uri="{521415D9-36F7-43E2-AB2F-B90AF26B5E84}">
       <p14:sectionLst xmlns:p14="http://schemas.microsoft.com/office/powerpoint/2010/main">
-        <p14:section name="Architecture" id="{b1d64a12-be16-8462-04c3-b5f16aa71bbf}">
+        <p14:section name="Architecture" id="{1b87f9e5-d908-8349-e006-388664dc2f32}">
           <p14:sldIdLst>
             <p14:sldId id="256"/>
             <p14:sldId id="257"/>
@@ -893,7 +893,7 @@
                 <a:ea typeface="Segoe UI" pitchFamily="34" charset="-122"/>
                 <a:cs typeface="Segoe UI" pitchFamily="34" charset="-120"/>
               </a:rPr>
-              <a:t>MadhuTwin architecture   ·   Anish Karthik Ayyagari, IIT Kharagpur</a:t>
+              <a:t>MadhuTwin architecture   ·   Team BioT   ·   Anish Karthik Ayyagari, IIT Kharagpur</a:t>
             </a:r>
             <a:endParaRPr lang="en-US" sz="900" dirty="0"/>
           </a:p>

</xml_diff>

<commit_message>
Add new-patient onboarding to the presentation and architecture
- New slide: a new patient's twin built from a CSV upload, with the
  sample's personalisation result
- Roadmap and architecture diagram list onboarding; the CSV path is shown
  as an input to the live streams
</commit_message>
<xml_diff>
--- a/docs/Architecture.pptx
+++ b/docs/Architecture.pptx
@@ -108,7 +108,7 @@
   <p:extLst>
     <p:ext uri="{521415D9-36F7-43E2-AB2F-B90AF26B5E84}">
       <p14:sectionLst xmlns:p14="http://schemas.microsoft.com/office/powerpoint/2010/main">
-        <p14:section name="Architecture" id="{1b87f9e5-d908-8349-e006-388664dc2f32}">
+        <p14:section name="Architecture" id="{eccd7009-7a83-8ffd-2090-f3551fc9b3ab}">
           <p14:sldIdLst>
             <p14:sldId id="256"/>
             <p14:sldId id="257"/>
@@ -2091,6 +2091,26 @@
             </a:r>
             <a:endParaRPr lang="en-US" sz="1050" dirty="0"/>
           </a:p>
+          <a:p>
+            <a:pPr indent="0" marL="0">
+              <a:spcAft>
+                <a:spcPts val="200"/>
+              </a:spcAft>
+              <a:buNone/>
+            </a:pPr>
+            <a:r>
+              <a:rPr lang="en-US" sz="1050" dirty="0">
+                <a:solidFill>
+                  <a:srgbClr val="2A2F36"/>
+                </a:solidFill>
+                <a:latin typeface="Segoe UI" pitchFamily="34" charset="0"/>
+                <a:ea typeface="Segoe UI" pitchFamily="34" charset="-122"/>
+                <a:cs typeface="Segoe UI" pitchFamily="34" charset="-120"/>
+              </a:rPr>
+              <a:t>Or a CSV export at onboarding</a:t>
+            </a:r>
+            <a:endParaRPr lang="en-US" sz="1050" dirty="0"/>
+          </a:p>
         </p:txBody>
       </p:sp>
       <p:sp>
@@ -3514,6 +3534,26 @@
                 <a:cs typeface="Segoe UI" pitchFamily="34" charset="-120"/>
               </a:rPr>
               <a:t>Coded health record</a:t>
+            </a:r>
+            <a:endParaRPr lang="en-US" sz="1050" dirty="0"/>
+          </a:p>
+          <a:p>
+            <a:pPr indent="0" marL="0">
+              <a:spcAft>
+                <a:spcPts val="200"/>
+              </a:spcAft>
+              <a:buNone/>
+            </a:pPr>
+            <a:r>
+              <a:rPr lang="en-US" sz="1050" dirty="0">
+                <a:solidFill>
+                  <a:srgbClr val="2A2F36"/>
+                </a:solidFill>
+                <a:latin typeface="Segoe UI" pitchFamily="34" charset="0"/>
+                <a:ea typeface="Segoe UI" pitchFamily="34" charset="-122"/>
+                <a:cs typeface="Segoe UI" pitchFamily="34" charset="-120"/>
+              </a:rPr>
+              <a:t>Patient onboarding</a:t>
             </a:r>
             <a:endParaRPr lang="en-US" sz="1050" dirty="0"/>
           </a:p>

</xml_diff>